<commit_message>
Close out: stale test counts, and the spec checklist marked honestly
Three deliverables claimed 74 or 75 tests when the suite had grown past both. A
test now counts the suite and compares it to the number README, the report and
the deck each state - the claim had already gone stale twice, which is twice more
than a number that easy to check should manage.

The spec's definition of done is filled in: five of seven ticked, two left open
and both reserved for Eileen rather than quietly claimed. NOTES.md defending the
headline metric is defined and defended in checkpoint3-metrics.md, but the spec
reserves that file for her. The four rehearsed answers are hers by definition.

82 tests green.

Co-Authored-By: Claude Opus 5 <noreply@anthropic.com>
</commit_message>
<xml_diff>
--- a/deliverables/streaming-engagement-deck.pptx
+++ b/deliverables/streaming-engagement-deck.pptx
@@ -4479,7 +4479,7 @@
                 <a:ea typeface="Calibri" pitchFamily="34" charset="-122"/>
                 <a:cs typeface="Calibri" pitchFamily="34" charset="-120"/>
               </a:rPr>
-              <a:t>Reproducible end to end: python -m src.match_report · src.model · src.analysis · src.dashboard. 75 tests. IMDb data used under its non-commercial terms. Interpretation drafted by the agent, 2026-09-27; the checkpoint decisions are Eileen's and are recorded in data/validation/.</a:t>
+              <a:t>Reproducible end to end: python -m src.match_report · src.model · src.analysis · src.dashboard. 82 tests. IMDb data used under its non-commercial terms. Interpretation drafted by the agent, 2026-09-27; the checkpoint decisions are Eileen's and are recorded in data/validation/.</a:t>
             </a:r>
             <a:endParaRPr lang="en-US" sz="1000" dirty="0"/>
           </a:p>
@@ -7696,7 +7696,7 @@
                 <a:ea typeface="Calibri" pitchFamily="34" charset="-122"/>
                 <a:cs typeface="Calibri" pitchFamily="34" charset="-120"/>
               </a:rPr>
-              <a:t>95% interval -0.03 to 0.17 — it contains zero</a:t>
+              <a:t>95% interval -0.03 to 0.16 — it contains zero</a:t>
             </a:r>
             <a:endParaRPr lang="en-US" sz="1200" dirty="0"/>
           </a:p>

</xml_diff>